<commit_message>
Adding new templates and images
</commit_message>
<xml_diff>
--- a/img_templates/so_status_preview.pptx
+++ b/img_templates/so_status_preview.pptx
@@ -2970,92 +2970,10 @@
       </p:grpSpPr>
       <p:sp>
         <p:nvSpPr>
-          <p:cNvPr id="4" name="TextBox 3">
+          <p:cNvPr id="10" name="Rectangle 9">
             <a:extLst>
               <a:ext uri="{FF2B5EF4-FFF2-40B4-BE49-F238E27FC236}">
-                <a16:creationId xmlns:a16="http://schemas.microsoft.com/office/drawing/2014/main" id="{FFD9F4D6-260B-67E6-7E75-95FE5C43B6C7}"/>
-              </a:ext>
-            </a:extLst>
-          </p:cNvPr>
-          <p:cNvSpPr txBox="1"/>
-          <p:nvPr/>
-        </p:nvSpPr>
-        <p:spPr>
-          <a:xfrm>
-            <a:off x="1168202" y="177800"/>
-            <a:ext cx="1321196" cy="769441"/>
-          </a:xfrm>
-          <a:prstGeom prst="rect">
-            <a:avLst/>
-          </a:prstGeom>
-          <a:noFill/>
-        </p:spPr>
-        <p:txBody>
-          <a:bodyPr wrap="none" rtlCol="0">
-            <a:spAutoFit/>
-          </a:bodyPr>
-          <a:lstStyle/>
-          <a:p>
-            <a:r>
-              <a:rPr lang="en-US" sz="4400" b="1" dirty="0">
-                <a:solidFill>
-                  <a:srgbClr val="F59E0B"/>
-                </a:solidFill>
-                <a:latin typeface="Segoe UI" panose="020B0502040204020203" pitchFamily="34" charset="0"/>
-                <a:cs typeface="Segoe UI" panose="020B0502040204020203" pitchFamily="34" charset="0"/>
-              </a:rPr>
-              <a:t>42%</a:t>
-            </a:r>
-          </a:p>
-        </p:txBody>
-      </p:sp>
-      <p:sp>
-        <p:nvSpPr>
-          <p:cNvPr id="5" name="TextBox 4">
-            <a:extLst>
-              <a:ext uri="{FF2B5EF4-FFF2-40B4-BE49-F238E27FC236}">
-                <a16:creationId xmlns:a16="http://schemas.microsoft.com/office/drawing/2014/main" id="{D0D570D3-165D-F096-11B2-00F907D696AB}"/>
-              </a:ext>
-            </a:extLst>
-          </p:cNvPr>
-          <p:cNvSpPr txBox="1"/>
-          <p:nvPr/>
-        </p:nvSpPr>
-        <p:spPr>
-          <a:xfrm>
-            <a:off x="1427632" y="777964"/>
-            <a:ext cx="802336" cy="338554"/>
-          </a:xfrm>
-          <a:prstGeom prst="rect">
-            <a:avLst/>
-          </a:prstGeom>
-          <a:noFill/>
-        </p:spPr>
-        <p:txBody>
-          <a:bodyPr wrap="none" rtlCol="0">
-            <a:spAutoFit/>
-          </a:bodyPr>
-          <a:lstStyle/>
-          <a:p>
-            <a:r>
-              <a:rPr lang="en-US" sz="1600" dirty="0">
-                <a:solidFill>
-                  <a:srgbClr val="F59E0B"/>
-                </a:solidFill>
-                <a:latin typeface="Segoe UI" panose="020B0502040204020203" pitchFamily="34" charset="0"/>
-                <a:cs typeface="Segoe UI" panose="020B0502040204020203" pitchFamily="34" charset="0"/>
-              </a:rPr>
-              <a:t>At Risk</a:t>
-            </a:r>
-          </a:p>
-        </p:txBody>
-      </p:sp>
-      <p:sp>
-        <p:nvSpPr>
-          <p:cNvPr id="6" name="Rounded Rectangle 5">
-            <a:extLst>
-              <a:ext uri="{FF2B5EF4-FFF2-40B4-BE49-F238E27FC236}">
-                <a16:creationId xmlns:a16="http://schemas.microsoft.com/office/drawing/2014/main" id="{C7E88E17-8EB3-BA31-92F7-196D85DD46F2}"/>
+                <a16:creationId xmlns:a16="http://schemas.microsoft.com/office/drawing/2014/main" id="{675E948B-6BF8-6E47-1761-F7710D709395}"/>
               </a:ext>
             </a:extLst>
           </p:cNvPr>
@@ -3064,14 +2982,16 @@
         </p:nvSpPr>
         <p:spPr>
           <a:xfrm>
-            <a:off x="92634" y="1168400"/>
-            <a:ext cx="1444066" cy="152400"/>
+            <a:off x="0" y="0"/>
+            <a:ext cx="1644650" cy="812800"/>
           </a:xfrm>
-          <a:prstGeom prst="roundRect">
+          <a:prstGeom prst="rect">
             <a:avLst/>
           </a:prstGeom>
           <a:solidFill>
-            <a:srgbClr val="EF4444"/>
+            <a:schemeClr val="bg1">
+              <a:lumMod val="95000"/>
+            </a:schemeClr>
           </a:solidFill>
           <a:ln>
             <a:noFill/>
@@ -3104,10 +3024,45 @@
       </p:sp>
       <p:sp>
         <p:nvSpPr>
-          <p:cNvPr id="7" name="Rounded Rectangle 6">
+          <p:cNvPr id="11" name="TextBox 10">
             <a:extLst>
               <a:ext uri="{FF2B5EF4-FFF2-40B4-BE49-F238E27FC236}">
-                <a16:creationId xmlns:a16="http://schemas.microsoft.com/office/drawing/2014/main" id="{96A24BA5-CDD4-1878-F675-3ED2A7DD68C7}"/>
+                <a16:creationId xmlns:a16="http://schemas.microsoft.com/office/drawing/2014/main" id="{57B2D473-66EB-9584-A065-DC9E2F5D6823}"/>
+              </a:ext>
+            </a:extLst>
+          </p:cNvPr>
+          <p:cNvSpPr txBox="1"/>
+          <p:nvPr/>
+        </p:nvSpPr>
+        <p:spPr>
+          <a:xfrm>
+            <a:off x="0" y="0"/>
+            <a:ext cx="558166" cy="307777"/>
+          </a:xfrm>
+          <a:prstGeom prst="rect">
+            <a:avLst/>
+          </a:prstGeom>
+          <a:noFill/>
+        </p:spPr>
+        <p:txBody>
+          <a:bodyPr wrap="none" rtlCol="0">
+            <a:spAutoFit/>
+          </a:bodyPr>
+          <a:lstStyle/>
+          <a:p>
+            <a:r>
+              <a:rPr lang="en-US" sz="1400" b="1" dirty="0"/>
+              <a:t>SO 1</a:t>
+            </a:r>
+          </a:p>
+        </p:txBody>
+      </p:sp>
+      <p:sp>
+        <p:nvSpPr>
+          <p:cNvPr id="12" name="Rounded Rectangle 11">
+            <a:extLst>
+              <a:ext uri="{FF2B5EF4-FFF2-40B4-BE49-F238E27FC236}">
+                <a16:creationId xmlns:a16="http://schemas.microsoft.com/office/drawing/2014/main" id="{B37E5584-F8B3-22E8-38C3-719A6FBBCB67}"/>
               </a:ext>
             </a:extLst>
           </p:cNvPr>
@@ -3116,8 +3071,8 @@
         </p:nvSpPr>
         <p:spPr>
           <a:xfrm>
-            <a:off x="2643098" y="1168400"/>
-            <a:ext cx="921868" cy="152400"/>
+            <a:off x="31750" y="292100"/>
+            <a:ext cx="800100" cy="228600"/>
           </a:xfrm>
           <a:prstGeom prst="roundRect">
             <a:avLst/>
@@ -3150,16 +3105,58 @@
           <a:lstStyle/>
           <a:p>
             <a:pPr algn="ctr"/>
-            <a:endParaRPr lang="en-US" dirty="0"/>
-          </a:p>
-        </p:txBody>
-      </p:sp>
-      <p:sp>
-        <p:nvSpPr>
-          <p:cNvPr id="8" name="Rectangle 7">
+            <a:r>
+              <a:rPr lang="en-US" sz="1200" dirty="0"/>
+              <a:t>On Track</a:t>
+            </a:r>
+          </a:p>
+        </p:txBody>
+      </p:sp>
+      <p:sp>
+        <p:nvSpPr>
+          <p:cNvPr id="13" name="TextBox 12">
             <a:extLst>
               <a:ext uri="{FF2B5EF4-FFF2-40B4-BE49-F238E27FC236}">
-                <a16:creationId xmlns:a16="http://schemas.microsoft.com/office/drawing/2014/main" id="{6BACA812-F1C6-E8D9-BD17-AAF471FA68B3}"/>
+                <a16:creationId xmlns:a16="http://schemas.microsoft.com/office/drawing/2014/main" id="{43E4129C-C726-A9C8-C9D7-FD6DB3D10709}"/>
+              </a:ext>
+            </a:extLst>
+          </p:cNvPr>
+          <p:cNvSpPr txBox="1"/>
+          <p:nvPr/>
+        </p:nvSpPr>
+        <p:spPr>
+          <a:xfrm>
+            <a:off x="1169840" y="307201"/>
+            <a:ext cx="474810" cy="276999"/>
+          </a:xfrm>
+          <a:prstGeom prst="rect">
+            <a:avLst/>
+          </a:prstGeom>
+          <a:noFill/>
+        </p:spPr>
+        <p:txBody>
+          <a:bodyPr wrap="none" rtlCol="0">
+            <a:spAutoFit/>
+          </a:bodyPr>
+          <a:lstStyle/>
+          <a:p>
+            <a:r>
+              <a:rPr lang="en-US" sz="1200" b="1" dirty="0">
+                <a:solidFill>
+                  <a:srgbClr val="22C55E"/>
+                </a:solidFill>
+              </a:rPr>
+              <a:t>78%</a:t>
+            </a:r>
+          </a:p>
+        </p:txBody>
+      </p:sp>
+      <p:sp>
+        <p:nvSpPr>
+          <p:cNvPr id="15" name="Rectangle 14">
+            <a:extLst>
+              <a:ext uri="{FF2B5EF4-FFF2-40B4-BE49-F238E27FC236}">
+                <a16:creationId xmlns:a16="http://schemas.microsoft.com/office/drawing/2014/main" id="{F15A50C0-425D-5A94-F0CC-71884D08A6B4}"/>
               </a:ext>
             </a:extLst>
           </p:cNvPr>
@@ -3167,15 +3164,17 @@
           <p:nvPr/>
         </p:nvSpPr>
         <p:spPr>
-          <a:xfrm>
-            <a:off x="1536700" y="1168400"/>
-            <a:ext cx="1332002" cy="152400"/>
+          <a:xfrm flipV="1">
+            <a:off x="390822" y="613479"/>
+            <a:ext cx="1138090" cy="45719"/>
           </a:xfrm>
           <a:prstGeom prst="rect">
             <a:avLst/>
           </a:prstGeom>
           <a:solidFill>
-            <a:srgbClr val="F59E0B"/>
+            <a:schemeClr val="bg1">
+              <a:lumMod val="85000"/>
+            </a:schemeClr>
           </a:solidFill>
           <a:ln>
             <a:noFill/>
@@ -3208,39 +3207,53 @@
       </p:sp>
       <p:sp>
         <p:nvSpPr>
-          <p:cNvPr id="9" name="TextBox 8">
+          <p:cNvPr id="14" name="Rectangle 13">
             <a:extLst>
               <a:ext uri="{FF2B5EF4-FFF2-40B4-BE49-F238E27FC236}">
-                <a16:creationId xmlns:a16="http://schemas.microsoft.com/office/drawing/2014/main" id="{6F2F7DB4-9C48-7CED-6D96-135112E5549E}"/>
+                <a16:creationId xmlns:a16="http://schemas.microsoft.com/office/drawing/2014/main" id="{FDB4015A-D18F-1AD5-EDE6-020D63DE8CFA}"/>
               </a:ext>
             </a:extLst>
           </p:cNvPr>
-          <p:cNvSpPr txBox="1"/>
+          <p:cNvSpPr/>
           <p:nvPr/>
         </p:nvSpPr>
         <p:spPr>
-          <a:xfrm>
-            <a:off x="298450" y="1541959"/>
-            <a:ext cx="3060700" cy="276999"/>
+          <a:xfrm flipV="1">
+            <a:off x="31750" y="613479"/>
+            <a:ext cx="1138090" cy="45719"/>
           </a:xfrm>
           <a:prstGeom prst="rect">
             <a:avLst/>
           </a:prstGeom>
-          <a:noFill/>
+          <a:solidFill>
+            <a:srgbClr val="22C55E"/>
+          </a:solidFill>
+          <a:ln>
+            <a:noFill/>
+          </a:ln>
         </p:spPr>
-        <p:txBody>
-          <a:bodyPr wrap="square" rtlCol="0">
-            <a:spAutoFit/>
-          </a:bodyPr>
-          <a:lstStyle/>
-          <a:p>
-            <a:r>
-              <a:rPr lang="en-US" sz="1200" dirty="0">
-                <a:latin typeface="Segoe UI" panose="020B0502040204020203" pitchFamily="34" charset="0"/>
-                <a:cs typeface="Segoe UI" panose="020B0502040204020203" pitchFamily="34" charset="0"/>
-              </a:rPr>
-              <a:t>🔴 Critical: 5 🟠 At Risk: 4  🟢 On Track: 3</a:t>
-            </a:r>
+        <p:style>
+          <a:lnRef idx="2">
+            <a:schemeClr val="accent1">
+              <a:shade val="15000"/>
+            </a:schemeClr>
+          </a:lnRef>
+          <a:fillRef idx="1">
+            <a:schemeClr val="accent1"/>
+          </a:fillRef>
+          <a:effectRef idx="0">
+            <a:schemeClr val="accent1"/>
+          </a:effectRef>
+          <a:fontRef idx="minor">
+            <a:schemeClr val="lt1"/>
+          </a:fontRef>
+        </p:style>
+        <p:txBody>
+          <a:bodyPr rtlCol="0" anchor="ctr"/>
+          <a:lstStyle/>
+          <a:p>
+            <a:pPr algn="ctr"/>
+            <a:endParaRPr lang="en-US"/>
           </a:p>
         </p:txBody>
       </p:sp>

</xml_diff>